<commit_message>
shrimp task master에 계획 요청
</commit_message>
<xml_diff>
--- a/PPT정리/28. Shrimp Task Master AI- 97,107강 내용.pptx
+++ b/PPT정리/28. Shrimp Task Master AI- 97,107강 내용.pptx
@@ -358,7 +358,7 @@
           <a:p>
             <a:fld id="{FDCCB462-B40D-428D-8FC4-842D104849FE}" type="datetimeFigureOut">
               <a:rPr lang="ko-KR" altLang="en-US" smtClean="0"/>
-              <a:t>2026-07-02</a:t>
+              <a:t>2026-07-03</a:t>
             </a:fld>
             <a:endParaRPr lang="ko-KR" altLang="en-US"/>
           </a:p>
@@ -566,7 +566,7 @@
           <a:p>
             <a:fld id="{FDCCB462-B40D-428D-8FC4-842D104849FE}" type="datetimeFigureOut">
               <a:rPr lang="ko-KR" altLang="en-US" smtClean="0"/>
-              <a:t>2026-07-02</a:t>
+              <a:t>2026-07-03</a:t>
             </a:fld>
             <a:endParaRPr lang="ko-KR" altLang="en-US"/>
           </a:p>
@@ -822,7 +822,7 @@
           <a:p>
             <a:fld id="{FDCCB462-B40D-428D-8FC4-842D104849FE}" type="datetimeFigureOut">
               <a:rPr lang="ko-KR" altLang="en-US" smtClean="0"/>
-              <a:t>2026-07-02</a:t>
+              <a:t>2026-07-03</a:t>
             </a:fld>
             <a:endParaRPr lang="ko-KR" altLang="en-US"/>
           </a:p>
@@ -996,7 +996,7 @@
           <a:p>
             <a:fld id="{FDCCB462-B40D-428D-8FC4-842D104849FE}" type="datetimeFigureOut">
               <a:rPr lang="ko-KR" altLang="en-US" smtClean="0"/>
-              <a:t>2026-07-02</a:t>
+              <a:t>2026-07-03</a:t>
             </a:fld>
             <a:endParaRPr lang="ko-KR" altLang="en-US"/>
           </a:p>
@@ -1339,7 +1339,7 @@
           <a:p>
             <a:fld id="{FDCCB462-B40D-428D-8FC4-842D104849FE}" type="datetimeFigureOut">
               <a:rPr lang="ko-KR" altLang="en-US" smtClean="0"/>
-              <a:t>2026-07-02</a:t>
+              <a:t>2026-07-03</a:t>
             </a:fld>
             <a:endParaRPr lang="ko-KR" altLang="en-US"/>
           </a:p>
@@ -1614,7 +1614,7 @@
           <a:p>
             <a:fld id="{FDCCB462-B40D-428D-8FC4-842D104849FE}" type="datetimeFigureOut">
               <a:rPr lang="ko-KR" altLang="en-US" smtClean="0"/>
-              <a:t>2026-07-02</a:t>
+              <a:t>2026-07-03</a:t>
             </a:fld>
             <a:endParaRPr lang="ko-KR" altLang="en-US"/>
           </a:p>
@@ -1993,7 +1993,7 @@
           <a:p>
             <a:fld id="{FDCCB462-B40D-428D-8FC4-842D104849FE}" type="datetimeFigureOut">
               <a:rPr lang="ko-KR" altLang="en-US" smtClean="0"/>
-              <a:t>2026-07-02</a:t>
+              <a:t>2026-07-03</a:t>
             </a:fld>
             <a:endParaRPr lang="ko-KR" altLang="en-US"/>
           </a:p>
@@ -2111,7 +2111,7 @@
           <a:p>
             <a:fld id="{FDCCB462-B40D-428D-8FC4-842D104849FE}" type="datetimeFigureOut">
               <a:rPr lang="ko-KR" altLang="en-US" smtClean="0"/>
-              <a:t>2026-07-02</a:t>
+              <a:t>2026-07-03</a:t>
             </a:fld>
             <a:endParaRPr lang="ko-KR" altLang="en-US"/>
           </a:p>
@@ -2282,7 +2282,7 @@
           <a:p>
             <a:fld id="{FDCCB462-B40D-428D-8FC4-842D104849FE}" type="datetimeFigureOut">
               <a:rPr lang="ko-KR" altLang="en-US" smtClean="0"/>
-              <a:t>2026-07-02</a:t>
+              <a:t>2026-07-03</a:t>
             </a:fld>
             <a:endParaRPr lang="ko-KR" altLang="en-US"/>
           </a:p>
@@ -2636,7 +2636,7 @@
           <a:p>
             <a:fld id="{FDCCB462-B40D-428D-8FC4-842D104849FE}" type="datetimeFigureOut">
               <a:rPr lang="ko-KR" altLang="en-US" smtClean="0"/>
-              <a:t>2026-07-02</a:t>
+              <a:t>2026-07-03</a:t>
             </a:fld>
             <a:endParaRPr lang="ko-KR" altLang="en-US"/>
           </a:p>
@@ -3018,7 +3018,7 @@
           <a:p>
             <a:fld id="{FDCCB462-B40D-428D-8FC4-842D104849FE}" type="datetimeFigureOut">
               <a:rPr lang="ko-KR" altLang="en-US" smtClean="0"/>
-              <a:t>2026-07-02</a:t>
+              <a:t>2026-07-03</a:t>
             </a:fld>
             <a:endParaRPr lang="ko-KR" altLang="en-US"/>
           </a:p>
@@ -3305,7 +3305,7 @@
           <a:p>
             <a:fld id="{FDCCB462-B40D-428D-8FC4-842D104849FE}" type="datetimeFigureOut">
               <a:rPr lang="ko-KR" altLang="en-US" smtClean="0"/>
-              <a:t>2026-07-02</a:t>
+              <a:t>2026-07-03</a:t>
             </a:fld>
             <a:endParaRPr lang="ko-KR" altLang="en-US"/>
           </a:p>

</xml_diff>